<commit_message>
feat(ai-native): session 04 on acceptance criteria and work units
- S04: acceptance criteria as allow/reject examples, JUnit 5 acceptance tests,
  work units ending in an acceptance test, feature list, definition of done,
  and a real demo (agent writes its own tests vs. is given acceptance tests)
- code/s04: order implementation, acceptance tests, features.json, demo records
- production: lead text joins a short code block's slide; a single diagram
  leaves the text what it does not need at 8pt; warn on bullets that start
  with a circled number
- drop sync/async labels from the practice model package and S01 code
- project allowlist in .claude/settings.json

Co-Authored-By: Claude Opus 5.5 <noreply@anthropic.com>
</commit_message>
<xml_diff>
--- a/courses/ai-native/sessions/s03.pptx
+++ b/courses/ai-native/sessions/s03.pptx
@@ -17582,7 +17582,7 @@
         <p:spPr>
           <a:xfrm>
             <a:off x="365760" y="960120"/>
-            <a:ext cx="8412480" cy="2514600"/>
+            <a:ext cx="8412480" cy="2360168"/>
           </a:xfrm>
         </p:spPr>
         <p:txBody>
@@ -17796,7 +17796,7 @@
         </p:nvSpPr>
         <p:spPr>
           <a:xfrm>
-            <a:off x="365760" y="3949030"/>
+            <a:off x="365760" y="3718144"/>
             <a:ext cx="8412480" cy="274320"/>
           </a:xfrm>
           <a:prstGeom prst="rect">
@@ -17840,8 +17840,8 @@
         </p:blipFill>
         <p:spPr>
           <a:xfrm>
-            <a:off x="2938849" y="4223350"/>
-            <a:ext cx="3266302" cy="2153123"/>
+            <a:off x="2801938" y="3992464"/>
+            <a:ext cx="3540125" cy="2333625"/>
           </a:xfrm>
           <a:prstGeom prst="rect">
             <a:avLst/>

</xml_diff>